<commit_message>
Adding lots of pictures and diagrams to the project and the documentation. Plus small changes in the code.
</commit_message>
<xml_diff>
--- a/Pictures/Bemutató1.pptx
+++ b/Pictures/Bemutató1.pptx
@@ -8,6 +8,7 @@
     <p:sldId id="256" r:id="rId2"/>
     <p:sldId id="257" r:id="rId3"/>
     <p:sldId id="258" r:id="rId4"/>
+    <p:sldId id="259" r:id="rId5"/>
   </p:sldIdLst>
   <p:sldSz cx="12192000" cy="6858000"/>
   <p:notesSz cx="6858000" cy="9144000"/>
@@ -3343,7 +3344,7 @@
           <p:nvPr>
             <p:extLst>
               <p:ext uri="{D42A27DB-BD31-4B8C-83A1-F6EECF244321}">
-                <p14:modId xmlns:p14="http://schemas.microsoft.com/office/powerpoint/2010/main" val="2322755869"/>
+                <p14:modId xmlns:p14="http://schemas.microsoft.com/office/powerpoint/2010/main" val="2418952363"/>
               </p:ext>
             </p:extLst>
           </p:nvPr>
@@ -3590,7 +3591,7 @@
                     <a:bodyPr/>
                     <a:lstStyle/>
                     <a:p>
-                      <a:endParaRPr lang="hu-HU" dirty="0"/>
+                      <a:endParaRPr lang="hu-HU" noProof="1"/>
                     </a:p>
                   </a:txBody>
                   <a:tcPr>
@@ -3643,7 +3644,7 @@
                     <a:bodyPr/>
                     <a:lstStyle/>
                     <a:p>
-                      <a:endParaRPr lang="hu-HU" dirty="0"/>
+                      <a:endParaRPr lang="hu-HU" noProof="1"/>
                     </a:p>
                   </a:txBody>
                   <a:tcPr>
@@ -3693,7 +3694,7 @@
                     <a:bodyPr/>
                     <a:lstStyle/>
                     <a:p>
-                      <a:endParaRPr lang="hu-HU" dirty="0"/>
+                      <a:endParaRPr lang="hu-HU" noProof="1"/>
                     </a:p>
                   </a:txBody>
                   <a:tcPr>
@@ -3743,7 +3744,7 @@
                     <a:bodyPr/>
                     <a:lstStyle/>
                     <a:p>
-                      <a:endParaRPr lang="hu-HU" dirty="0"/>
+                      <a:endParaRPr lang="hu-HU" noProof="1"/>
                     </a:p>
                   </a:txBody>
                   <a:tcPr>
@@ -3793,7 +3794,7 @@
                     <a:bodyPr/>
                     <a:lstStyle/>
                     <a:p>
-                      <a:endParaRPr lang="hu-HU" dirty="0"/>
+                      <a:endParaRPr lang="hu-HU" noProof="1"/>
                     </a:p>
                   </a:txBody>
                   <a:tcPr>
@@ -3843,7 +3844,7 @@
                     <a:bodyPr/>
                     <a:lstStyle/>
                     <a:p>
-                      <a:endParaRPr lang="hu-HU" dirty="0"/>
+                      <a:endParaRPr lang="hu-HU" noProof="1"/>
                     </a:p>
                   </a:txBody>
                   <a:tcPr>
@@ -3893,7 +3894,7 @@
                     <a:bodyPr/>
                     <a:lstStyle/>
                     <a:p>
-                      <a:endParaRPr lang="hu-HU" dirty="0"/>
+                      <a:endParaRPr lang="hu-HU" noProof="1"/>
                     </a:p>
                   </a:txBody>
                   <a:tcPr>
@@ -3943,7 +3944,7 @@
                     <a:bodyPr/>
                     <a:lstStyle/>
                     <a:p>
-                      <a:endParaRPr lang="hu-HU" dirty="0"/>
+                      <a:endParaRPr lang="hu-HU" noProof="1"/>
                     </a:p>
                   </a:txBody>
                   <a:tcPr>
@@ -3993,7 +3994,7 @@
                     <a:bodyPr/>
                     <a:lstStyle/>
                     <a:p>
-                      <a:endParaRPr lang="hu-HU" dirty="0"/>
+                      <a:endParaRPr lang="hu-HU" noProof="1"/>
                     </a:p>
                   </a:txBody>
                   <a:tcPr>
@@ -4043,7 +4044,7 @@
                     <a:bodyPr/>
                     <a:lstStyle/>
                     <a:p>
-                      <a:endParaRPr lang="hu-HU" dirty="0"/>
+                      <a:endParaRPr lang="hu-HU" noProof="1"/>
                     </a:p>
                   </a:txBody>
                   <a:tcPr>
@@ -4093,7 +4094,7 @@
                     <a:bodyPr/>
                     <a:lstStyle/>
                     <a:p>
-                      <a:endParaRPr lang="hu-HU" dirty="0"/>
+                      <a:endParaRPr lang="hu-HU" noProof="1"/>
                     </a:p>
                   </a:txBody>
                   <a:tcPr>
@@ -4143,7 +4144,7 @@
                     <a:bodyPr/>
                     <a:lstStyle/>
                     <a:p>
-                      <a:endParaRPr lang="hu-HU" dirty="0"/>
+                      <a:endParaRPr lang="hu-HU" noProof="1"/>
                     </a:p>
                   </a:txBody>
                   <a:tcPr>
@@ -4193,7 +4194,7 @@
                     <a:bodyPr/>
                     <a:lstStyle/>
                     <a:p>
-                      <a:endParaRPr lang="hu-HU" dirty="0"/>
+                      <a:endParaRPr lang="hu-HU" noProof="1"/>
                     </a:p>
                   </a:txBody>
                   <a:tcPr>
@@ -4243,7 +4244,7 @@
                     <a:bodyPr/>
                     <a:lstStyle/>
                     <a:p>
-                      <a:endParaRPr lang="hu-HU" dirty="0"/>
+                      <a:endParaRPr lang="hu-HU" noProof="1"/>
                     </a:p>
                   </a:txBody>
                   <a:tcPr>
@@ -4293,7 +4294,7 @@
                     <a:bodyPr/>
                     <a:lstStyle/>
                     <a:p>
-                      <a:endParaRPr lang="hu-HU" dirty="0"/>
+                      <a:endParaRPr lang="hu-HU" noProof="1"/>
                     </a:p>
                   </a:txBody>
                   <a:tcPr>
@@ -4343,7 +4344,7 @@
                     <a:bodyPr/>
                     <a:lstStyle/>
                     <a:p>
-                      <a:endParaRPr lang="hu-HU" dirty="0"/>
+                      <a:endParaRPr lang="hu-HU" noProof="1"/>
                     </a:p>
                   </a:txBody>
                   <a:tcPr>
@@ -4393,7 +4394,7 @@
                     <a:bodyPr/>
                     <a:lstStyle/>
                     <a:p>
-                      <a:endParaRPr lang="hu-HU" dirty="0"/>
+                      <a:endParaRPr lang="hu-HU" noProof="1"/>
                     </a:p>
                   </a:txBody>
                   <a:tcPr>
@@ -4443,7 +4444,7 @@
                     <a:bodyPr/>
                     <a:lstStyle/>
                     <a:p>
-                      <a:endParaRPr lang="hu-HU" dirty="0"/>
+                      <a:endParaRPr lang="hu-HU" noProof="1"/>
                     </a:p>
                   </a:txBody>
                   <a:tcPr>
@@ -4493,7 +4494,7 @@
                     <a:bodyPr/>
                     <a:lstStyle/>
                     <a:p>
-                      <a:endParaRPr lang="hu-HU" dirty="0"/>
+                      <a:endParaRPr lang="hu-HU" noProof="1"/>
                     </a:p>
                   </a:txBody>
                   <a:tcPr>
@@ -4543,7 +4544,7 @@
                     <a:bodyPr/>
                     <a:lstStyle/>
                     <a:p>
-                      <a:endParaRPr lang="hu-HU" dirty="0"/>
+                      <a:endParaRPr lang="hu-HU" noProof="1"/>
                     </a:p>
                   </a:txBody>
                   <a:tcPr>
@@ -4593,7 +4594,7 @@
                     <a:bodyPr/>
                     <a:lstStyle/>
                     <a:p>
-                      <a:endParaRPr lang="hu-HU" dirty="0"/>
+                      <a:endParaRPr lang="hu-HU" noProof="1"/>
                     </a:p>
                   </a:txBody>
                   <a:tcPr>
@@ -4643,7 +4644,7 @@
                     <a:bodyPr/>
                     <a:lstStyle/>
                     <a:p>
-                      <a:endParaRPr lang="hu-HU" dirty="0"/>
+                      <a:endParaRPr lang="hu-HU" noProof="1"/>
                     </a:p>
                   </a:txBody>
                   <a:tcPr>
@@ -4693,7 +4694,7 @@
                     <a:bodyPr/>
                     <a:lstStyle/>
                     <a:p>
-                      <a:endParaRPr lang="hu-HU" dirty="0"/>
+                      <a:endParaRPr lang="hu-HU" noProof="1"/>
                     </a:p>
                   </a:txBody>
                   <a:tcPr>
@@ -4743,7 +4744,7 @@
                     <a:bodyPr/>
                     <a:lstStyle/>
                     <a:p>
-                      <a:endParaRPr lang="hu-HU" dirty="0"/>
+                      <a:endParaRPr lang="hu-HU" noProof="1"/>
                     </a:p>
                   </a:txBody>
                   <a:tcPr>
@@ -4793,7 +4794,7 @@
                     <a:bodyPr/>
                     <a:lstStyle/>
                     <a:p>
-                      <a:endParaRPr lang="hu-HU" dirty="0"/>
+                      <a:endParaRPr lang="hu-HU" noProof="1"/>
                     </a:p>
                   </a:txBody>
                   <a:tcPr>
@@ -4843,7 +4844,7 @@
                     <a:bodyPr/>
                     <a:lstStyle/>
                     <a:p>
-                      <a:endParaRPr lang="hu-HU" dirty="0"/>
+                      <a:endParaRPr lang="hu-HU" noProof="1"/>
                     </a:p>
                   </a:txBody>
                   <a:tcPr>
@@ -4893,7 +4894,7 @@
                     <a:bodyPr/>
                     <a:lstStyle/>
                     <a:p>
-                      <a:endParaRPr lang="hu-HU" dirty="0"/>
+                      <a:endParaRPr lang="hu-HU" noProof="1"/>
                     </a:p>
                   </a:txBody>
                   <a:tcPr>
@@ -4943,7 +4944,7 @@
                     <a:bodyPr/>
                     <a:lstStyle/>
                     <a:p>
-                      <a:endParaRPr lang="hu-HU" dirty="0"/>
+                      <a:endParaRPr lang="hu-HU" noProof="1"/>
                     </a:p>
                   </a:txBody>
                   <a:tcPr>
@@ -4993,7 +4994,7 @@
                     <a:bodyPr/>
                     <a:lstStyle/>
                     <a:p>
-                      <a:endParaRPr lang="hu-HU" dirty="0"/>
+                      <a:endParaRPr lang="hu-HU" noProof="1"/>
                     </a:p>
                   </a:txBody>
                   <a:tcPr>
@@ -5043,7 +5044,7 @@
                     <a:bodyPr/>
                     <a:lstStyle/>
                     <a:p>
-                      <a:endParaRPr lang="hu-HU" dirty="0"/>
+                      <a:endParaRPr lang="hu-HU" noProof="1"/>
                     </a:p>
                   </a:txBody>
                   <a:tcPr>
@@ -5093,7 +5094,7 @@
                     <a:bodyPr/>
                     <a:lstStyle/>
                     <a:p>
-                      <a:endParaRPr lang="hu-HU" dirty="0"/>
+                      <a:endParaRPr lang="hu-HU" noProof="1"/>
                     </a:p>
                   </a:txBody>
                   <a:tcPr>
@@ -5143,7 +5144,7 @@
                     <a:bodyPr/>
                     <a:lstStyle/>
                     <a:p>
-                      <a:endParaRPr lang="hu-HU" dirty="0"/>
+                      <a:endParaRPr lang="hu-HU" noProof="1"/>
                     </a:p>
                   </a:txBody>
                   <a:tcPr>
@@ -5275,7 +5276,7 @@
           <a:p>
             <a:pPr algn="ctr"/>
             <a:r>
-              <a:rPr lang="hu-HU" dirty="0">
+              <a:rPr lang="hu-HU" noProof="1">
                 <a:solidFill>
                   <a:schemeClr val="tx1"/>
                 </a:solidFill>
@@ -5285,23 +5286,23 @@
           </a:p>
           <a:p>
             <a:pPr algn="ctr"/>
-            <a:endParaRPr lang="hu-HU" dirty="0"/>
+            <a:endParaRPr lang="hu-HU" noProof="1"/>
           </a:p>
           <a:p>
             <a:pPr algn="ctr"/>
-            <a:endParaRPr lang="hu-HU" dirty="0"/>
+            <a:endParaRPr lang="hu-HU" noProof="1"/>
           </a:p>
           <a:p>
             <a:pPr algn="ctr"/>
-            <a:endParaRPr lang="hu-HU" dirty="0"/>
+            <a:endParaRPr lang="hu-HU" noProof="1"/>
           </a:p>
           <a:p>
             <a:pPr algn="ctr"/>
-            <a:endParaRPr lang="hu-HU" dirty="0"/>
+            <a:endParaRPr lang="hu-HU" noProof="1"/>
           </a:p>
           <a:p>
             <a:pPr algn="ctr"/>
-            <a:endParaRPr lang="hu-HU" dirty="0"/>
+            <a:endParaRPr lang="hu-HU" noProof="1"/>
           </a:p>
         </p:txBody>
       </p:sp>
@@ -5352,7 +5353,7 @@
           <a:p>
             <a:pPr algn="ctr"/>
             <a:r>
-              <a:rPr lang="hu-HU" dirty="0">
+              <a:rPr lang="hu-HU" noProof="1">
                 <a:solidFill>
                   <a:schemeClr val="tx1"/>
                 </a:solidFill>
@@ -5362,23 +5363,23 @@
           </a:p>
           <a:p>
             <a:pPr algn="ctr"/>
-            <a:endParaRPr lang="hu-HU" dirty="0"/>
+            <a:endParaRPr lang="hu-HU" noProof="1"/>
           </a:p>
           <a:p>
             <a:pPr algn="ctr"/>
-            <a:endParaRPr lang="hu-HU" dirty="0"/>
+            <a:endParaRPr lang="hu-HU" noProof="1"/>
           </a:p>
           <a:p>
             <a:pPr algn="ctr"/>
-            <a:endParaRPr lang="hu-HU" dirty="0"/>
+            <a:endParaRPr lang="hu-HU" noProof="1"/>
           </a:p>
           <a:p>
             <a:pPr algn="ctr"/>
-            <a:endParaRPr lang="hu-HU" dirty="0"/>
+            <a:endParaRPr lang="hu-HU" noProof="1"/>
           </a:p>
           <a:p>
             <a:pPr algn="ctr"/>
-            <a:endParaRPr lang="hu-HU" dirty="0"/>
+            <a:endParaRPr lang="hu-HU" noProof="1"/>
           </a:p>
         </p:txBody>
       </p:sp>
@@ -5425,7 +5426,7 @@
           <a:p>
             <a:pPr algn="ctr"/>
             <a:r>
-              <a:rPr lang="hu-HU" sz="1600" dirty="0"/>
+              <a:rPr lang="hu-HU" sz="1600" noProof="1"/>
               <a:t>Beérkezik a kiszámolandó egyenlet</a:t>
             </a:r>
           </a:p>
@@ -5474,7 +5475,7 @@
           <a:p>
             <a:pPr algn="ctr"/>
             <a:r>
-              <a:rPr lang="hu-HU" sz="1600" dirty="0"/>
+              <a:rPr lang="hu-HU" sz="1600" noProof="1"/>
               <a:t>Tokenizálás</a:t>
             </a:r>
           </a:p>
@@ -5523,7 +5524,7 @@
           <a:p>
             <a:pPr algn="ctr"/>
             <a:r>
-              <a:rPr lang="hu-HU" sz="1600" dirty="0"/>
+              <a:rPr lang="hu-HU" sz="1600" noProof="1"/>
               <a:t>Lengyel formára hozás</a:t>
             </a:r>
           </a:p>
@@ -5572,7 +5573,7 @@
           <a:p>
             <a:pPr algn="ctr"/>
             <a:r>
-              <a:rPr lang="hu-HU" sz="1600" dirty="0"/>
+              <a:rPr lang="hu-HU" sz="1600" noProof="1"/>
               <a:t>Kifejezésfa elkészítése</a:t>
             </a:r>
           </a:p>
@@ -5621,7 +5622,7 @@
           <a:p>
             <a:pPr algn="ctr"/>
             <a:r>
-              <a:rPr lang="hu-HU" sz="1600" dirty="0"/>
+              <a:rPr lang="hu-HU" sz="1600" noProof="1"/>
               <a:t>Kiértékelés mélységi bejárással</a:t>
             </a:r>
           </a:p>
@@ -5845,7 +5846,7 @@
           <a:p>
             <a:pPr algn="ctr"/>
             <a:r>
-              <a:rPr lang="hu-HU" sz="1600" dirty="0"/>
+              <a:rPr lang="hu-HU" sz="1600" noProof="1"/>
               <a:t>Eredmény</a:t>
             </a:r>
           </a:p>
@@ -5939,7 +5940,7 @@
           <p:nvPr>
             <p:extLst>
               <p:ext uri="{D42A27DB-BD31-4B8C-83A1-F6EECF244321}">
-                <p14:modId xmlns:p14="http://schemas.microsoft.com/office/powerpoint/2010/main" val="2507566737"/>
+                <p14:modId xmlns:p14="http://schemas.microsoft.com/office/powerpoint/2010/main" val="2366609622"/>
               </p:ext>
             </p:extLst>
           </p:nvPr>
@@ -6042,14 +6043,6 @@
                         </a:rPr>
                         <a:t>[1-9][0-9]*\.[0-9]+</a:t>
                       </a:r>
-                      <a:endParaRPr lang="hu-HU" sz="4800" b="0" dirty="0">
-                        <a:solidFill>
-                          <a:schemeClr val="tx1"/>
-                        </a:solidFill>
-                        <a:highlight>
-                          <a:srgbClr val="FF0000"/>
-                        </a:highlight>
-                      </a:endParaRPr>
                     </a:p>
                   </a:txBody>
                   <a:tcPr>
@@ -6099,7 +6092,7 @@
                         <a:defRPr/>
                       </a:pPr>
                       <a:r>
-                        <a:rPr lang="hu-HU" sz="4800" b="0" dirty="0">
+                        <a:rPr lang="hu-HU" sz="4800" b="0" noProof="1">
                           <a:solidFill>
                             <a:schemeClr val="tx1"/>
                           </a:solidFill>
@@ -6126,7 +6119,7 @@
                         <a:defRPr/>
                       </a:pPr>
                       <a:r>
-                        <a:rPr lang="hu-HU" sz="4800" b="0" dirty="0">
+                        <a:rPr lang="hu-HU" sz="4800" b="0" noProof="1">
                           <a:solidFill>
                             <a:schemeClr val="tx1"/>
                           </a:solidFill>
@@ -6137,7 +6130,7 @@
                         <a:t>2718</a:t>
                       </a:r>
                       <a:r>
-                        <a:rPr lang="hu-HU" sz="4800" b="0" dirty="0">
+                        <a:rPr lang="hu-HU" sz="4800" b="0" noProof="1">
                           <a:solidFill>
                             <a:schemeClr val="tx1"/>
                           </a:solidFill>
@@ -6146,7 +6139,7 @@
                       </a:r>
                     </a:p>
                     <a:p>
-                      <a:endParaRPr lang="hu-HU" sz="4800" b="0" dirty="0">
+                      <a:endParaRPr lang="hu-HU" sz="4800" b="0" noProof="1">
                         <a:solidFill>
                           <a:schemeClr val="tx1"/>
                         </a:solidFill>
@@ -6191,6 +6184,620 @@
     <p:extLst>
       <p:ext uri="{BB962C8B-B14F-4D97-AF65-F5344CB8AC3E}">
         <p14:creationId xmlns:p14="http://schemas.microsoft.com/office/powerpoint/2010/main" val="1146536456"/>
+      </p:ext>
+    </p:extLst>
+  </p:cSld>
+  <p:clrMapOvr>
+    <a:masterClrMapping/>
+  </p:clrMapOvr>
+</p:sld>
+</file>
+
+<file path=ppt/slides/slide4.xml><?xml version="1.0" encoding="utf-8"?>
+<p:sld xmlns:a="http://schemas.openxmlformats.org/drawingml/2006/main" xmlns:r="http://schemas.openxmlformats.org/officeDocument/2006/relationships" xmlns:p="http://schemas.openxmlformats.org/presentationml/2006/main">
+  <p:cSld>
+    <p:spTree>
+      <p:nvGrpSpPr>
+        <p:cNvPr id="1" name=""/>
+        <p:cNvGrpSpPr/>
+        <p:nvPr/>
+      </p:nvGrpSpPr>
+      <p:grpSpPr>
+        <a:xfrm>
+          <a:off x="0" y="0"/>
+          <a:ext cx="0" cy="0"/>
+          <a:chOff x="0" y="0"/>
+          <a:chExt cx="0" cy="0"/>
+        </a:xfrm>
+      </p:grpSpPr>
+      <p:sp>
+        <p:nvSpPr>
+          <p:cNvPr id="5" name="Téglalap: lekerekített 4">
+            <a:extLst>
+              <a:ext uri="{FF2B5EF4-FFF2-40B4-BE49-F238E27FC236}">
+                <a16:creationId xmlns:a16="http://schemas.microsoft.com/office/drawing/2014/main" id="{0618C48D-49F3-472D-CBBC-4CBD3858C0B0}"/>
+              </a:ext>
+            </a:extLst>
+          </p:cNvPr>
+          <p:cNvSpPr/>
+          <p:nvPr/>
+        </p:nvSpPr>
+        <p:spPr>
+          <a:xfrm>
+            <a:off x="4945930" y="2108461"/>
+            <a:ext cx="2300140" cy="1320539"/>
+          </a:xfrm>
+          <a:prstGeom prst="roundRect">
+            <a:avLst/>
+          </a:prstGeom>
+          <a:solidFill>
+            <a:schemeClr val="accent1">
+              <a:lumMod val="60000"/>
+              <a:lumOff val="40000"/>
+            </a:schemeClr>
+          </a:solidFill>
+          <a:ln>
+            <a:noFill/>
+          </a:ln>
+        </p:spPr>
+        <p:style>
+          <a:lnRef idx="2">
+            <a:schemeClr val="accent1">
+              <a:shade val="15000"/>
+            </a:schemeClr>
+          </a:lnRef>
+          <a:fillRef idx="1">
+            <a:schemeClr val="accent1"/>
+          </a:fillRef>
+          <a:effectRef idx="0">
+            <a:schemeClr val="accent1"/>
+          </a:effectRef>
+          <a:fontRef idx="minor">
+            <a:schemeClr val="lt1"/>
+          </a:fontRef>
+        </p:style>
+        <p:txBody>
+          <a:bodyPr rtlCol="0" anchor="ctr"/>
+          <a:lstStyle/>
+          <a:p>
+            <a:pPr algn="ctr"/>
+            <a:r>
+              <a:rPr lang="hu-HU" sz="2400" noProof="1"/>
+              <a:t>ViewModel</a:t>
+            </a:r>
+          </a:p>
+        </p:txBody>
+      </p:sp>
+      <p:grpSp>
+        <p:nvGrpSpPr>
+          <p:cNvPr id="7" name="Csoportba foglalás 6">
+            <a:extLst>
+              <a:ext uri="{FF2B5EF4-FFF2-40B4-BE49-F238E27FC236}">
+                <a16:creationId xmlns:a16="http://schemas.microsoft.com/office/drawing/2014/main" id="{6A9DF171-912B-2299-17F3-534B543DE34A}"/>
+              </a:ext>
+            </a:extLst>
+          </p:cNvPr>
+          <p:cNvGrpSpPr/>
+          <p:nvPr/>
+        </p:nvGrpSpPr>
+        <p:grpSpPr>
+          <a:xfrm>
+            <a:off x="1994554" y="3984395"/>
+            <a:ext cx="8202891" cy="1320539"/>
+            <a:chOff x="2677212" y="3465921"/>
+            <a:chExt cx="8202891" cy="1320539"/>
+          </a:xfrm>
+        </p:grpSpPr>
+        <p:sp>
+          <p:nvSpPr>
+            <p:cNvPr id="4" name="Téglalap: lekerekített 3">
+              <a:extLst>
+                <a:ext uri="{FF2B5EF4-FFF2-40B4-BE49-F238E27FC236}">
+                  <a16:creationId xmlns:a16="http://schemas.microsoft.com/office/drawing/2014/main" id="{F2FF13C8-EDE3-1767-1446-DCDE4507A206}"/>
+                </a:ext>
+              </a:extLst>
+            </p:cNvPr>
+            <p:cNvSpPr/>
+            <p:nvPr/>
+          </p:nvSpPr>
+          <p:spPr>
+            <a:xfrm>
+              <a:off x="2677212" y="3465921"/>
+              <a:ext cx="2300140" cy="1320539"/>
+            </a:xfrm>
+            <a:prstGeom prst="roundRect">
+              <a:avLst/>
+            </a:prstGeom>
+            <a:solidFill>
+              <a:srgbClr val="FBB753"/>
+            </a:solidFill>
+            <a:ln>
+              <a:noFill/>
+            </a:ln>
+          </p:spPr>
+          <p:style>
+            <a:lnRef idx="2">
+              <a:schemeClr val="accent1">
+                <a:shade val="15000"/>
+              </a:schemeClr>
+            </a:lnRef>
+            <a:fillRef idx="1">
+              <a:schemeClr val="accent1"/>
+            </a:fillRef>
+            <a:effectRef idx="0">
+              <a:schemeClr val="accent1"/>
+            </a:effectRef>
+            <a:fontRef idx="minor">
+              <a:schemeClr val="lt1"/>
+            </a:fontRef>
+          </p:style>
+          <p:txBody>
+            <a:bodyPr rtlCol="0" anchor="ctr"/>
+            <a:lstStyle/>
+            <a:p>
+              <a:pPr algn="ctr"/>
+              <a:r>
+                <a:rPr lang="hu-HU" sz="2400" noProof="1"/>
+                <a:t>Model</a:t>
+              </a:r>
+            </a:p>
+          </p:txBody>
+        </p:sp>
+        <p:sp>
+          <p:nvSpPr>
+            <p:cNvPr id="6" name="Téglalap: lekerekített 5">
+              <a:extLst>
+                <a:ext uri="{FF2B5EF4-FFF2-40B4-BE49-F238E27FC236}">
+                  <a16:creationId xmlns:a16="http://schemas.microsoft.com/office/drawing/2014/main" id="{A0249D09-687D-89EF-43CA-F638BBD84599}"/>
+                </a:ext>
+              </a:extLst>
+            </p:cNvPr>
+            <p:cNvSpPr/>
+            <p:nvPr/>
+          </p:nvSpPr>
+          <p:spPr>
+            <a:xfrm>
+              <a:off x="8579963" y="3465921"/>
+              <a:ext cx="2300140" cy="1320539"/>
+            </a:xfrm>
+            <a:prstGeom prst="roundRect">
+              <a:avLst/>
+            </a:prstGeom>
+            <a:solidFill>
+              <a:schemeClr val="accent3">
+                <a:lumMod val="60000"/>
+                <a:lumOff val="40000"/>
+              </a:schemeClr>
+            </a:solidFill>
+            <a:ln>
+              <a:noFill/>
+            </a:ln>
+          </p:spPr>
+          <p:style>
+            <a:lnRef idx="2">
+              <a:schemeClr val="accent1">
+                <a:shade val="15000"/>
+              </a:schemeClr>
+            </a:lnRef>
+            <a:fillRef idx="1">
+              <a:schemeClr val="accent1"/>
+            </a:fillRef>
+            <a:effectRef idx="0">
+              <a:schemeClr val="accent1"/>
+            </a:effectRef>
+            <a:fontRef idx="minor">
+              <a:schemeClr val="lt1"/>
+            </a:fontRef>
+          </p:style>
+          <p:txBody>
+            <a:bodyPr rtlCol="0" anchor="ctr"/>
+            <a:lstStyle/>
+            <a:p>
+              <a:pPr algn="ctr"/>
+              <a:r>
+                <a:rPr lang="hu-HU" sz="2400" noProof="1"/>
+                <a:t>View</a:t>
+              </a:r>
+            </a:p>
+          </p:txBody>
+        </p:sp>
+      </p:grpSp>
+      <p:sp>
+        <p:nvSpPr>
+          <p:cNvPr id="10" name="Nyíl: kanyarodó 9">
+            <a:extLst>
+              <a:ext uri="{FF2B5EF4-FFF2-40B4-BE49-F238E27FC236}">
+                <a16:creationId xmlns:a16="http://schemas.microsoft.com/office/drawing/2014/main" id="{AAB88164-6E2F-611B-630E-6F7B3C8C4569}"/>
+              </a:ext>
+            </a:extLst>
+          </p:cNvPr>
+          <p:cNvSpPr/>
+          <p:nvPr/>
+        </p:nvSpPr>
+        <p:spPr>
+          <a:xfrm>
+            <a:off x="3579042" y="2743201"/>
+            <a:ext cx="1247482" cy="1121790"/>
+          </a:xfrm>
+          <a:prstGeom prst="bentArrow">
+            <a:avLst>
+              <a:gd name="adj1" fmla="val 1306"/>
+              <a:gd name="adj2" fmla="val 3091"/>
+              <a:gd name="adj3" fmla="val 9112"/>
+              <a:gd name="adj4" fmla="val 43750"/>
+            </a:avLst>
+          </a:prstGeom>
+          <a:solidFill>
+            <a:schemeClr val="tx1"/>
+          </a:solidFill>
+          <a:ln>
+            <a:solidFill>
+              <a:schemeClr val="tx1"/>
+            </a:solidFill>
+          </a:ln>
+        </p:spPr>
+        <p:style>
+          <a:lnRef idx="2">
+            <a:schemeClr val="accent1">
+              <a:shade val="15000"/>
+            </a:schemeClr>
+          </a:lnRef>
+          <a:fillRef idx="1">
+            <a:schemeClr val="accent1"/>
+          </a:fillRef>
+          <a:effectRef idx="0">
+            <a:schemeClr val="accent1"/>
+          </a:effectRef>
+          <a:fontRef idx="minor">
+            <a:schemeClr val="lt1"/>
+          </a:fontRef>
+        </p:style>
+        <p:txBody>
+          <a:bodyPr rtlCol="0" anchor="ctr"/>
+          <a:lstStyle/>
+          <a:p>
+            <a:pPr algn="ctr"/>
+            <a:endParaRPr lang="hu-HU" noProof="1">
+              <a:solidFill>
+                <a:schemeClr val="tx1"/>
+              </a:solidFill>
+            </a:endParaRPr>
+          </a:p>
+        </p:txBody>
+      </p:sp>
+      <p:sp>
+        <p:nvSpPr>
+          <p:cNvPr id="11" name="Nyíl: kanyarodó 10">
+            <a:extLst>
+              <a:ext uri="{FF2B5EF4-FFF2-40B4-BE49-F238E27FC236}">
+                <a16:creationId xmlns:a16="http://schemas.microsoft.com/office/drawing/2014/main" id="{67237632-E7BA-F663-C624-5FF9A2909025}"/>
+              </a:ext>
+            </a:extLst>
+          </p:cNvPr>
+          <p:cNvSpPr/>
+          <p:nvPr/>
+        </p:nvSpPr>
+        <p:spPr>
+          <a:xfrm flipH="1" flipV="1">
+            <a:off x="4389748" y="3551156"/>
+            <a:ext cx="1247481" cy="1121790"/>
+          </a:xfrm>
+          <a:prstGeom prst="bentArrow">
+            <a:avLst>
+              <a:gd name="adj1" fmla="val 1306"/>
+              <a:gd name="adj2" fmla="val 3091"/>
+              <a:gd name="adj3" fmla="val 9112"/>
+              <a:gd name="adj4" fmla="val 43750"/>
+            </a:avLst>
+          </a:prstGeom>
+          <a:solidFill>
+            <a:schemeClr val="tx1"/>
+          </a:solidFill>
+          <a:ln>
+            <a:solidFill>
+              <a:schemeClr val="tx1"/>
+            </a:solidFill>
+          </a:ln>
+        </p:spPr>
+        <p:style>
+          <a:lnRef idx="2">
+            <a:schemeClr val="accent1">
+              <a:shade val="15000"/>
+            </a:schemeClr>
+          </a:lnRef>
+          <a:fillRef idx="1">
+            <a:schemeClr val="accent1"/>
+          </a:fillRef>
+          <a:effectRef idx="0">
+            <a:schemeClr val="accent1"/>
+          </a:effectRef>
+          <a:fontRef idx="minor">
+            <a:schemeClr val="lt1"/>
+          </a:fontRef>
+        </p:style>
+        <p:txBody>
+          <a:bodyPr rtlCol="0" anchor="ctr"/>
+          <a:lstStyle/>
+          <a:p>
+            <a:pPr algn="ctr"/>
+            <a:endParaRPr lang="hu-HU" noProof="1">
+              <a:solidFill>
+                <a:schemeClr val="tx1"/>
+              </a:solidFill>
+            </a:endParaRPr>
+          </a:p>
+        </p:txBody>
+      </p:sp>
+      <p:sp>
+        <p:nvSpPr>
+          <p:cNvPr id="12" name="Nyíl: kanyarodó 11">
+            <a:extLst>
+              <a:ext uri="{FF2B5EF4-FFF2-40B4-BE49-F238E27FC236}">
+                <a16:creationId xmlns:a16="http://schemas.microsoft.com/office/drawing/2014/main" id="{897FBBE2-B78E-FCCD-A6C0-A99C7BB363BB}"/>
+              </a:ext>
+            </a:extLst>
+          </p:cNvPr>
+          <p:cNvSpPr/>
+          <p:nvPr/>
+        </p:nvSpPr>
+        <p:spPr>
+          <a:xfrm flipV="1">
+            <a:off x="6554770" y="3551156"/>
+            <a:ext cx="1247481" cy="1121790"/>
+          </a:xfrm>
+          <a:prstGeom prst="bentArrow">
+            <a:avLst>
+              <a:gd name="adj1" fmla="val 1306"/>
+              <a:gd name="adj2" fmla="val 3091"/>
+              <a:gd name="adj3" fmla="val 9112"/>
+              <a:gd name="adj4" fmla="val 43750"/>
+            </a:avLst>
+          </a:prstGeom>
+          <a:solidFill>
+            <a:schemeClr val="tx1"/>
+          </a:solidFill>
+          <a:ln>
+            <a:solidFill>
+              <a:schemeClr val="tx1"/>
+            </a:solidFill>
+          </a:ln>
+        </p:spPr>
+        <p:style>
+          <a:lnRef idx="2">
+            <a:schemeClr val="accent1">
+              <a:shade val="15000"/>
+            </a:schemeClr>
+          </a:lnRef>
+          <a:fillRef idx="1">
+            <a:schemeClr val="accent1"/>
+          </a:fillRef>
+          <a:effectRef idx="0">
+            <a:schemeClr val="accent1"/>
+          </a:effectRef>
+          <a:fontRef idx="minor">
+            <a:schemeClr val="lt1"/>
+          </a:fontRef>
+        </p:style>
+        <p:txBody>
+          <a:bodyPr rtlCol="0" anchor="ctr"/>
+          <a:lstStyle/>
+          <a:p>
+            <a:pPr algn="ctr"/>
+            <a:endParaRPr lang="hu-HU" noProof="1">
+              <a:solidFill>
+                <a:schemeClr val="tx1"/>
+              </a:solidFill>
+            </a:endParaRPr>
+          </a:p>
+        </p:txBody>
+      </p:sp>
+      <p:sp>
+        <p:nvSpPr>
+          <p:cNvPr id="13" name="Nyíl: kanyarodó 12">
+            <a:extLst>
+              <a:ext uri="{FF2B5EF4-FFF2-40B4-BE49-F238E27FC236}">
+                <a16:creationId xmlns:a16="http://schemas.microsoft.com/office/drawing/2014/main" id="{306D2143-E8DF-81B4-2E16-0A02F679F84C}"/>
+              </a:ext>
+            </a:extLst>
+          </p:cNvPr>
+          <p:cNvSpPr/>
+          <p:nvPr/>
+        </p:nvSpPr>
+        <p:spPr>
+          <a:xfrm flipH="1">
+            <a:off x="7365476" y="2740451"/>
+            <a:ext cx="1247482" cy="1121790"/>
+          </a:xfrm>
+          <a:prstGeom prst="bentArrow">
+            <a:avLst>
+              <a:gd name="adj1" fmla="val 1306"/>
+              <a:gd name="adj2" fmla="val 3091"/>
+              <a:gd name="adj3" fmla="val 9112"/>
+              <a:gd name="adj4" fmla="val 43750"/>
+            </a:avLst>
+          </a:prstGeom>
+          <a:solidFill>
+            <a:schemeClr val="tx1"/>
+          </a:solidFill>
+          <a:ln>
+            <a:solidFill>
+              <a:schemeClr val="tx1"/>
+            </a:solidFill>
+          </a:ln>
+        </p:spPr>
+        <p:style>
+          <a:lnRef idx="2">
+            <a:schemeClr val="accent1">
+              <a:shade val="15000"/>
+            </a:schemeClr>
+          </a:lnRef>
+          <a:fillRef idx="1">
+            <a:schemeClr val="accent1"/>
+          </a:fillRef>
+          <a:effectRef idx="0">
+            <a:schemeClr val="accent1"/>
+          </a:effectRef>
+          <a:fontRef idx="minor">
+            <a:schemeClr val="lt1"/>
+          </a:fontRef>
+        </p:style>
+        <p:txBody>
+          <a:bodyPr rtlCol="0" anchor="ctr"/>
+          <a:lstStyle/>
+          <a:p>
+            <a:pPr algn="ctr"/>
+            <a:endParaRPr lang="hu-HU" noProof="1">
+              <a:solidFill>
+                <a:schemeClr val="tx1"/>
+              </a:solidFill>
+            </a:endParaRPr>
+          </a:p>
+        </p:txBody>
+      </p:sp>
+      <p:sp>
+        <p:nvSpPr>
+          <p:cNvPr id="14" name="Szövegdoboz 13">
+            <a:extLst>
+              <a:ext uri="{FF2B5EF4-FFF2-40B4-BE49-F238E27FC236}">
+                <a16:creationId xmlns:a16="http://schemas.microsoft.com/office/drawing/2014/main" id="{6B56D925-EFF0-4298-F77E-F80250641DF8}"/>
+              </a:ext>
+            </a:extLst>
+          </p:cNvPr>
+          <p:cNvSpPr txBox="1"/>
+          <p:nvPr/>
+        </p:nvSpPr>
+        <p:spPr>
+          <a:xfrm>
+            <a:off x="2853536" y="2623797"/>
+            <a:ext cx="822918" cy="369332"/>
+          </a:xfrm>
+          <a:prstGeom prst="rect">
+            <a:avLst/>
+          </a:prstGeom>
+          <a:noFill/>
+        </p:spPr>
+        <p:txBody>
+          <a:bodyPr wrap="none" rtlCol="0">
+            <a:spAutoFit/>
+          </a:bodyPr>
+          <a:lstStyle/>
+          <a:p>
+            <a:r>
+              <a:rPr lang="hu-HU" b="1" noProof="1"/>
+              <a:t>Notify</a:t>
+            </a:r>
+          </a:p>
+        </p:txBody>
+      </p:sp>
+      <p:sp>
+        <p:nvSpPr>
+          <p:cNvPr id="15" name="Szövegdoboz 14">
+            <a:extLst>
+              <a:ext uri="{FF2B5EF4-FFF2-40B4-BE49-F238E27FC236}">
+                <a16:creationId xmlns:a16="http://schemas.microsoft.com/office/drawing/2014/main" id="{1CB4216A-FCC8-0B3A-829B-CC3B0BE1752E}"/>
+              </a:ext>
+            </a:extLst>
+          </p:cNvPr>
+          <p:cNvSpPr txBox="1"/>
+          <p:nvPr/>
+        </p:nvSpPr>
+        <p:spPr>
+          <a:xfrm>
+            <a:off x="8515546" y="2555785"/>
+            <a:ext cx="773930" cy="369332"/>
+          </a:xfrm>
+          <a:prstGeom prst="rect">
+            <a:avLst/>
+          </a:prstGeom>
+          <a:noFill/>
+        </p:spPr>
+        <p:txBody>
+          <a:bodyPr wrap="none" rtlCol="0">
+            <a:spAutoFit/>
+          </a:bodyPr>
+          <a:lstStyle/>
+          <a:p>
+            <a:r>
+              <a:rPr lang="hu-HU" b="1" noProof="1"/>
+              <a:t>Event</a:t>
+            </a:r>
+          </a:p>
+        </p:txBody>
+      </p:sp>
+      <p:sp>
+        <p:nvSpPr>
+          <p:cNvPr id="16" name="Szövegdoboz 15">
+            <a:extLst>
+              <a:ext uri="{FF2B5EF4-FFF2-40B4-BE49-F238E27FC236}">
+                <a16:creationId xmlns:a16="http://schemas.microsoft.com/office/drawing/2014/main" id="{DB7B99DF-ADEF-421F-21DB-062C6734DCC7}"/>
+              </a:ext>
+            </a:extLst>
+          </p:cNvPr>
+          <p:cNvSpPr txBox="1"/>
+          <p:nvPr/>
+        </p:nvSpPr>
+        <p:spPr>
+          <a:xfrm>
+            <a:off x="4814311" y="4672946"/>
+            <a:ext cx="948273" cy="369332"/>
+          </a:xfrm>
+          <a:prstGeom prst="rect">
+            <a:avLst/>
+          </a:prstGeom>
+          <a:noFill/>
+        </p:spPr>
+        <p:txBody>
+          <a:bodyPr wrap="none" rtlCol="0">
+            <a:spAutoFit/>
+          </a:bodyPr>
+          <a:lstStyle/>
+          <a:p>
+            <a:r>
+              <a:rPr lang="hu-HU" b="1" noProof="1"/>
+              <a:t>Update</a:t>
+            </a:r>
+          </a:p>
+        </p:txBody>
+      </p:sp>
+      <p:sp>
+        <p:nvSpPr>
+          <p:cNvPr id="17" name="Szövegdoboz 16">
+            <a:extLst>
+              <a:ext uri="{FF2B5EF4-FFF2-40B4-BE49-F238E27FC236}">
+                <a16:creationId xmlns:a16="http://schemas.microsoft.com/office/drawing/2014/main" id="{F75527A9-434B-BC49-6AD7-CF87CF10C02A}"/>
+              </a:ext>
+            </a:extLst>
+          </p:cNvPr>
+          <p:cNvSpPr txBox="1"/>
+          <p:nvPr/>
+        </p:nvSpPr>
+        <p:spPr>
+          <a:xfrm>
+            <a:off x="6392167" y="4644664"/>
+            <a:ext cx="971741" cy="369332"/>
+          </a:xfrm>
+          <a:prstGeom prst="rect">
+            <a:avLst/>
+          </a:prstGeom>
+          <a:noFill/>
+        </p:spPr>
+        <p:txBody>
+          <a:bodyPr wrap="none" rtlCol="0">
+            <a:spAutoFit/>
+          </a:bodyPr>
+          <a:lstStyle/>
+          <a:p>
+            <a:r>
+              <a:rPr lang="hu-HU" b="1" noProof="1"/>
+              <a:t>Binding</a:t>
+            </a:r>
+          </a:p>
+        </p:txBody>
+      </p:sp>
+    </p:spTree>
+    <p:extLst>
+      <p:ext uri="{BB962C8B-B14F-4D97-AF65-F5344CB8AC3E}">
+        <p14:creationId xmlns:p14="http://schemas.microsoft.com/office/powerpoint/2010/main" val="3070118959"/>
       </p:ext>
     </p:extLst>
   </p:cSld>

</xml_diff>